<commit_message>
docs: update ProManage presentation with simplified words and Jenkins pipeline info
</commit_message>
<xml_diff>
--- a/ProManage_Presentation.pptx
+++ b/ProManage_Presentation.pptx
@@ -3177,42 +3177,36 @@
               </a:defRPr>
             </a:pPr>
             <a:r>
-              <a:t>ProManage 🚀</a:t>
-            </a:r>
-          </a:p>
-          <a:p>
-            <a:pPr>
-              <a:spcBef>
-                <a:spcPts val="1500"/>
-              </a:spcBef>
-              <a:defRPr sz="2800">
-                <a:solidFill>
-                  <a:srgbClr val="FFFFFF"/>
-                </a:solidFill>
-                <a:latin typeface="Arial"/>
-              </a:defRPr>
-            </a:pPr>
-            <a:r>
-              <a:t>A Premium MERN SaaS Task Management</a:t>
-            </a:r>
-            <a:br/>
-            <a:r>
-              <a:t>&amp; DevOps Platform</a:t>
-            </a:r>
-          </a:p>
-          <a:p>
-            <a:pPr>
-              <a:spcBef>
-                <a:spcPts val="4000"/>
-              </a:spcBef>
-              <a:defRPr sz="1600">
-                <a:solidFill>
-                  <a:srgbClr val="64748B"/>
-                </a:solidFill>
-                <a:latin typeface="Arial"/>
-              </a:defRPr>
-            </a:pPr>
-            <a:r>
+              <a:rPr sz="2800" b="1">
+                <a:solidFill>
+                  <a:srgbClr val="333333"/>
+                </a:solidFill>
+                <a:latin typeface="Segoe UI"/>
+              </a:rPr>
+              <a:t>ProManage 🚀
+</a:t>
+            </a:r>
+          </a:p>
+          <a:p>
+            <a:r>
+              <a:rPr sz="1500" b="0">
+                <a:solidFill>
+                  <a:srgbClr val="333333"/>
+                </a:solidFill>
+                <a:latin typeface="Segoe UI"/>
+              </a:rPr>
+              <a:t>A Simple &amp; Premium Task Management &amp; DevOps Platform
+</a:t>
+            </a:r>
+          </a:p>
+          <a:p>
+            <a:r>
+              <a:rPr sz="1300" b="0">
+                <a:solidFill>
+                  <a:srgbClr val="333333"/>
+                </a:solidFill>
+                <a:latin typeface="Segoe UI"/>
+              </a:rPr>
               <a:t>Presented by: Prashant Kumar Sharma</a:t>
             </a:r>
           </a:p>
@@ -3449,55 +3443,50 @@
               </a:defRPr>
             </a:pPr>
             <a:r>
-              <a:t>The Challenge</a:t>
-            </a:r>
-          </a:p>
-          <a:p>
-            <a:pPr>
-              <a:spcAft>
-                <a:spcPts val="1200"/>
-              </a:spcAft>
-              <a:defRPr sz="1500">
-                <a:solidFill>
-                  <a:srgbClr val="1E293B"/>
-                </a:solidFill>
-                <a:latin typeface="Arial"/>
-              </a:defRPr>
-            </a:pPr>
-            <a:r>
-              <a:t>• Traditional project management systems isolate source code progress, pipeline results, and infrastructure health from the core task board.</a:t>
-            </a:r>
-          </a:p>
-          <a:p>
-            <a:pPr>
-              <a:spcAft>
-                <a:spcPts val="1200"/>
-              </a:spcAft>
-              <a:defRPr sz="1500">
-                <a:solidFill>
-                  <a:srgbClr val="1E293B"/>
-                </a:solidFill>
-                <a:latin typeface="Arial"/>
-              </a:defRPr>
-            </a:pPr>
-            <a:r>
-              <a:t>• Developers, product managers, and admins are forced to juggle multiple tools (Jira, GitHub Actions, Docker Dashboard) to get a full view of project status.</a:t>
-            </a:r>
-          </a:p>
-          <a:p>
-            <a:pPr>
-              <a:spcAft>
-                <a:spcPts val="1200"/>
-              </a:spcAft>
-              <a:defRPr sz="1500">
-                <a:solidFill>
-                  <a:srgbClr val="1E293B"/>
-                </a:solidFill>
-                <a:latin typeface="Arial"/>
-              </a:defRPr>
-            </a:pPr>
-            <a:r>
-              <a:t>• Lack of central tracking leads to deployment bottlenecks, unmonitored server crashes, and slower release cycles.</a:t>
+              <a:rPr sz="1600" b="1">
+                <a:solidFill>
+                  <a:srgbClr val="333333"/>
+                </a:solidFill>
+                <a:latin typeface="Segoe UI"/>
+              </a:rPr>
+              <a:t>The Problem
+</a:t>
+            </a:r>
+          </a:p>
+          <a:p>
+            <a:pPr/>
+            <a:r>
+              <a:rPr sz="1300" b="0">
+                <a:solidFill>
+                  <a:srgbClr val="333333"/>
+                </a:solidFill>
+                <a:latin typeface="Segoe UI"/>
+              </a:rPr>
+              <a:t>• Too Many Tools: Teams must jump between Jira for tasks, GitHub for code, and Docker/Jenkins for server logs.</a:t>
+            </a:r>
+          </a:p>
+          <a:p>
+            <a:pPr/>
+            <a:r>
+              <a:rPr sz="1300" b="0">
+                <a:solidFill>
+                  <a:srgbClr val="333333"/>
+                </a:solidFill>
+                <a:latin typeface="Segoe UI"/>
+              </a:rPr>
+              <a:t>• Disconnected Data: It is hard to see if a task is actually deployed or if the server is running fine.</a:t>
+            </a:r>
+          </a:p>
+          <a:p>
+            <a:pPr/>
+            <a:r>
+              <a:rPr sz="1300" b="0">
+                <a:solidFill>
+                  <a:srgbClr val="333333"/>
+                </a:solidFill>
+                <a:latin typeface="Segoe UI"/>
+              </a:rPr>
+              <a:t>• Release Delays: This disconnect leads to communication gaps, slower deployments, and server crashes.</a:t>
             </a:r>
           </a:p>
         </p:txBody>
@@ -3525,22 +3514,50 @@
           <a:lstStyle/>
           <a:p>
             <a:r>
-              <a:t>The Solution: ProManage</a:t>
-            </a:r>
-          </a:p>
-          <a:p>
-            <a:r>
-              <a:t>• A unified DevOps SaaS platform combining drag-and-drop Kanban task boards with real-time DevOps metrics.</a:t>
-            </a:r>
-          </a:p>
-          <a:p>
-            <a:r>
-              <a:t>• Clickable metrics cards on the dashboard and interactive landing page feature cards for seamless user navigation.</a:t>
-            </a:r>
-          </a:p>
-          <a:p>
-            <a:r>
-              <a:t>• Interactive analytics dashboards that sync task updates, deployment histories, and pipeline feedback loops seamlessly.</a:t>
+              <a:rPr sz="1600" b="1">
+                <a:solidFill>
+                  <a:srgbClr val="333333"/>
+                </a:solidFill>
+                <a:latin typeface="Segoe UI"/>
+              </a:rPr>
+              <a:t>The Solution: ProManage
+</a:t>
+            </a:r>
+          </a:p>
+          <a:p>
+            <a:pPr/>
+            <a:r>
+              <a:rPr sz="1300" b="0">
+                <a:solidFill>
+                  <a:srgbClr val="333333"/>
+                </a:solidFill>
+                <a:latin typeface="Segoe UI"/>
+              </a:rPr>
+              <a:t>• Single Dashboard: A unified screen showing both your Kanban task board and your live container status.</a:t>
+            </a:r>
+          </a:p>
+          <a:p>
+            <a:pPr/>
+            <a:r>
+              <a:rPr sz="1300" b="0">
+                <a:solidFill>
+                  <a:srgbClr val="333333"/>
+                </a:solidFill>
+                <a:latin typeface="Segoe UI"/>
+              </a:rPr>
+              <a:t>• Live Feedback: Dashboard metrics are clickable, letting you filter tasks on the board instantly.</a:t>
+            </a:r>
+          </a:p>
+          <a:p>
+            <a:pPr/>
+            <a:r>
+              <a:rPr sz="1300" b="0">
+                <a:solidFill>
+                  <a:srgbClr val="333333"/>
+                </a:solidFill>
+                <a:latin typeface="Segoe UI"/>
+              </a:rPr>
+              <a:t>• Real-time Sync: Keeps everyone aligned with live build status, container health, and deploy status.</a:t>
             </a:r>
           </a:p>
         </p:txBody>
@@ -3784,12 +3801,25 @@
           <a:lstStyle/>
           <a:p>
             <a:r>
-              <a:t>Drag-and-Drop Kanban</a:t>
-            </a:r>
-          </a:p>
-          <a:p>
-            <a:r>
-              <a:t>Fluid task drag-and-drop system. Supports URL-driven filtering (All, Pending, Completed) with dynamic column visibility and header tab controls.</a:t>
+              <a:rPr sz="1400" b="1">
+                <a:solidFill>
+                  <a:srgbClr val="333333"/>
+                </a:solidFill>
+                <a:latin typeface="Segoe UI"/>
+              </a:rPr>
+              <a:t>Drag-and-Drop Kanban
+</a:t>
+            </a:r>
+          </a:p>
+          <a:p>
+            <a:r>
+              <a:rPr sz="1150" b="0">
+                <a:solidFill>
+                  <a:srgbClr val="333333"/>
+                </a:solidFill>
+                <a:latin typeface="Segoe UI"/>
+              </a:rPr>
+              <a:t>Move tasks easily between columns. Click on stats widgets on the dashboard to filter tasks on the board instantly.</a:t>
             </a:r>
           </a:p>
         </p:txBody>
@@ -3847,23 +3877,25 @@
               </a:defRPr>
             </a:pPr>
             <a:r>
-              <a:t>Workspaces &amp; Teams</a:t>
-            </a:r>
-          </a:p>
-          <a:p>
-            <a:pPr algn="l">
-              <a:spcBef>
-                <a:spcPts val="1000"/>
-              </a:spcBef>
-              <a:defRPr sz="1400">
-                <a:solidFill>
-                  <a:srgbClr val="1E293B"/>
-                </a:solidFill>
-                <a:latin typeface="Arial"/>
-              </a:defRPr>
-            </a:pPr>
-            <a:r>
-              <a:t>Dedicated collaborative spaces for individual projects. Add members, manage profiles, track team-wide actions, and view logs.</a:t>
+              <a:rPr sz="1400" b="1">
+                <a:solidFill>
+                  <a:srgbClr val="333333"/>
+                </a:solidFill>
+                <a:latin typeface="Segoe UI"/>
+              </a:rPr>
+              <a:t>Workspaces &amp; Teams
+</a:t>
+            </a:r>
+          </a:p>
+          <a:p>
+            <a:r>
+              <a:rPr sz="1150" b="0">
+                <a:solidFill>
+                  <a:srgbClr val="333333"/>
+                </a:solidFill>
+                <a:latin typeface="Segoe UI"/>
+              </a:rPr>
+              <a:t>Organize tasks by projects. Add team members, manage user profiles, and track recent activities.</a:t>
             </a:r>
           </a:p>
         </p:txBody>
@@ -3921,23 +3953,25 @@
               </a:defRPr>
             </a:pPr>
             <a:r>
-              <a:t>Security &amp; Roles</a:t>
-            </a:r>
-          </a:p>
-          <a:p>
-            <a:pPr algn="l">
-              <a:spcBef>
-                <a:spcPts val="1000"/>
-              </a:spcBef>
-              <a:defRPr sz="1400">
-                <a:solidFill>
-                  <a:srgbClr val="1E293B"/>
-                </a:solidFill>
-                <a:latin typeface="Arial"/>
-              </a:defRPr>
-            </a:pPr>
-            <a:r>
-              <a:t>Role-Based Access Control (RBAC) ensuring precise permissions for Admin, Manager, and Developer tiers, reinforced with JWT auth.</a:t>
+              <a:rPr sz="1400" b="1">
+                <a:solidFill>
+                  <a:srgbClr val="333333"/>
+                </a:solidFill>
+                <a:latin typeface="Segoe UI"/>
+              </a:rPr>
+              <a:t>Security &amp; Roles
+</a:t>
+            </a:r>
+          </a:p>
+          <a:p>
+            <a:r>
+              <a:rPr sz="1150" b="0">
+                <a:solidFill>
+                  <a:srgbClr val="333333"/>
+                </a:solidFill>
+                <a:latin typeface="Segoe UI"/>
+              </a:rPr>
+              <a:t>Secure login using JWT. Role-Based Access Control (RBAC) keeps Admin, Manager, and Developer permissions safe.</a:t>
             </a:r>
           </a:p>
         </p:txBody>
@@ -4190,23 +4224,25 @@
               </a:defRPr>
             </a:pPr>
             <a:r>
-              <a:t>CI/CD &amp; Container Status</a:t>
-            </a:r>
-          </a:p>
-          <a:p>
-            <a:pPr algn="l">
-              <a:spcBef>
-                <a:spcPts val="1000"/>
-              </a:spcBef>
-              <a:defRPr sz="1500">
-                <a:solidFill>
-                  <a:srgbClr val="FFFFFF"/>
-                </a:solidFill>
-                <a:latin typeface="Arial"/>
-              </a:defRPr>
-            </a:pPr>
-            <a:r>
-              <a:t>Real-time tracking of code deployment pipelines (Checkout, Install, Test, Build, Deploy stages). Integrated Docker dashboard displaying host container names, CPU load, memory utilization, and network ports.</a:t>
+              <a:rPr sz="1400" b="1">
+                <a:solidFill>
+                  <a:srgbClr val="333333"/>
+                </a:solidFill>
+                <a:latin typeface="Segoe UI"/>
+              </a:rPr>
+              <a:t>CI/CD &amp; Container Status
+</a:t>
+            </a:r>
+          </a:p>
+          <a:p>
+            <a:r>
+              <a:rPr sz="1150" b="0">
+                <a:solidFill>
+                  <a:srgbClr val="333333"/>
+                </a:solidFill>
+                <a:latin typeface="Segoe UI"/>
+              </a:rPr>
+              <a:t>Monitor your build pipelines in real-time. View Docker container CPU, memory load, and ports inside the app.</a:t>
             </a:r>
           </a:p>
         </p:txBody>
@@ -4251,12 +4287,25 @@
           <a:lstStyle/>
           <a:p>
             <a:r>
-              <a:t>Interactive Analytics &amp; Clickable Dashboard</a:t>
-            </a:r>
-          </a:p>
-          <a:p>
-            <a:r>
-              <a:t>Metrics widgets (Total, Completed, Pending) now act as clickable shortcuts, dynamically filtering tasks on Kanban board. Syncs with real-time audit feeds.</a:t>
+              <a:rPr sz="1400" b="1">
+                <a:solidFill>
+                  <a:srgbClr val="333333"/>
+                </a:solidFill>
+                <a:latin typeface="Segoe UI"/>
+              </a:rPr>
+              <a:t>Interactive Analytics &amp; Jenkins
+</a:t>
+            </a:r>
+          </a:p>
+          <a:p>
+            <a:r>
+              <a:rPr sz="1150" b="0">
+                <a:solidFill>
+                  <a:srgbClr val="333333"/>
+                </a:solidFill>
+                <a:latin typeface="Segoe UI"/>
+              </a:rPr>
+              <a:t>See detailed charts of task distribution and server health. Integrated with local Jenkins for auto-build status.</a:t>
             </a:r>
           </a:p>
         </p:txBody>
@@ -4511,87 +4560,62 @@
               </a:defRPr>
             </a:pPr>
             <a:r>
-              <a:t>Frontend 💻</a:t>
-            </a:r>
-          </a:p>
-          <a:p>
-            <a:pPr>
-              <a:spcBef>
-                <a:spcPts val="800"/>
-              </a:spcBef>
-              <a:defRPr sz="1500">
-                <a:solidFill>
-                  <a:srgbClr val="1E293B"/>
-                </a:solidFill>
-                <a:latin typeface="Arial"/>
-              </a:defRPr>
-            </a:pPr>
-            <a:r>
-              <a:t>✔  React 18 &amp; TypeScript</a:t>
-            </a:r>
-          </a:p>
-          <a:p>
-            <a:pPr>
-              <a:spcBef>
-                <a:spcPts val="800"/>
-              </a:spcBef>
-              <a:defRPr sz="1500">
-                <a:solidFill>
-                  <a:srgbClr val="1E293B"/>
-                </a:solidFill>
-                <a:latin typeface="Arial"/>
-              </a:defRPr>
-            </a:pPr>
-            <a:r>
-              <a:t>✔  TailwindCSS &amp; CSS Grid</a:t>
-            </a:r>
-          </a:p>
-          <a:p>
-            <a:pPr>
-              <a:spcBef>
-                <a:spcPts val="800"/>
-              </a:spcBef>
-              <a:defRPr sz="1500">
-                <a:solidFill>
-                  <a:srgbClr val="1E293B"/>
-                </a:solidFill>
-                <a:latin typeface="Arial"/>
-              </a:defRPr>
-            </a:pPr>
-            <a:r>
-              <a:t>✔  Vite (Fast Bundler)</a:t>
-            </a:r>
-          </a:p>
-          <a:p>
-            <a:pPr>
-              <a:spcBef>
-                <a:spcPts val="800"/>
-              </a:spcBef>
-              <a:defRPr sz="1500">
-                <a:solidFill>
-                  <a:srgbClr val="1E293B"/>
-                </a:solidFill>
-                <a:latin typeface="Arial"/>
-              </a:defRPr>
-            </a:pPr>
-            <a:r>
-              <a:t>✔  Framer Motion (Animations)</a:t>
-            </a:r>
-          </a:p>
-          <a:p>
-            <a:pPr>
-              <a:spcBef>
-                <a:spcPts val="800"/>
-              </a:spcBef>
-              <a:defRPr sz="1500">
-                <a:solidFill>
-                  <a:srgbClr val="1E293B"/>
-                </a:solidFill>
-                <a:latin typeface="Arial"/>
-              </a:defRPr>
-            </a:pPr>
-            <a:r>
-              <a:t>✔  Recharts (Visualizations)</a:t>
+              <a:rPr sz="1400" b="1">
+                <a:solidFill>
+                  <a:srgbClr val="333333"/>
+                </a:solidFill>
+                <a:latin typeface="Segoe UI"/>
+              </a:rPr>
+              <a:t>Frontend 💻
+</a:t>
+            </a:r>
+          </a:p>
+          <a:p>
+            <a:pPr/>
+            <a:r>
+              <a:rPr sz="1150" b="0">
+                <a:solidFill>
+                  <a:srgbClr val="333333"/>
+                </a:solidFill>
+                <a:latin typeface="Segoe UI"/>
+              </a:rPr>
+              <a:t>✔ React &amp; TypeScript</a:t>
+            </a:r>
+          </a:p>
+          <a:p>
+            <a:pPr/>
+            <a:r>
+              <a:rPr sz="1150" b="0">
+                <a:solidFill>
+                  <a:srgbClr val="333333"/>
+                </a:solidFill>
+                <a:latin typeface="Segoe UI"/>
+              </a:rPr>
+              <a:t>✔ Vite (Fast developer builds)</a:t>
+            </a:r>
+          </a:p>
+          <a:p>
+            <a:pPr/>
+            <a:r>
+              <a:rPr sz="1150" b="0">
+                <a:solidFill>
+                  <a:srgbClr val="333333"/>
+                </a:solidFill>
+                <a:latin typeface="Segoe UI"/>
+              </a:rPr>
+              <a:t>✔ TailwindCSS for styling</a:t>
+            </a:r>
+          </a:p>
+          <a:p>
+            <a:pPr/>
+            <a:r>
+              <a:rPr sz="1150" b="0">
+                <a:solidFill>
+                  <a:srgbClr val="333333"/>
+                </a:solidFill>
+                <a:latin typeface="Segoe UI"/>
+              </a:rPr>
+              <a:t>✔ Recharts (Simple graphs)</a:t>
             </a:r>
           </a:p>
         </p:txBody>
@@ -4649,103 +4673,62 @@
               </a:defRPr>
             </a:pPr>
             <a:r>
-              <a:t>Backend ⚙️</a:t>
-            </a:r>
-          </a:p>
-          <a:p>
-            <a:pPr>
-              <a:spcBef>
-                <a:spcPts val="800"/>
-              </a:spcBef>
-              <a:defRPr sz="1500">
-                <a:solidFill>
-                  <a:srgbClr val="1E293B"/>
-                </a:solidFill>
-                <a:latin typeface="Arial"/>
-              </a:defRPr>
-            </a:pPr>
-            <a:r>
-              <a:t>✔  Node.js Runtime</a:t>
-            </a:r>
-          </a:p>
-          <a:p>
-            <a:pPr>
-              <a:spcBef>
-                <a:spcPts val="800"/>
-              </a:spcBef>
-              <a:defRPr sz="1500">
-                <a:solidFill>
-                  <a:srgbClr val="1E293B"/>
-                </a:solidFill>
-                <a:latin typeface="Arial"/>
-              </a:defRPr>
-            </a:pPr>
-            <a:r>
-              <a:t>✔  Express.js Framework</a:t>
-            </a:r>
-          </a:p>
-          <a:p>
-            <a:pPr>
-              <a:spcBef>
-                <a:spcPts val="800"/>
-              </a:spcBef>
-              <a:defRPr sz="1500">
-                <a:solidFill>
-                  <a:srgbClr val="1E293B"/>
-                </a:solidFill>
-                <a:latin typeface="Arial"/>
-              </a:defRPr>
-            </a:pPr>
-            <a:r>
-              <a:t>✔  MongoDB Document DB</a:t>
-            </a:r>
-          </a:p>
-          <a:p>
-            <a:pPr>
-              <a:spcBef>
-                <a:spcPts val="800"/>
-              </a:spcBef>
-              <a:defRPr sz="1500">
-                <a:solidFill>
-                  <a:srgbClr val="1E293B"/>
-                </a:solidFill>
-                <a:latin typeface="Arial"/>
-              </a:defRPr>
-            </a:pPr>
-            <a:r>
-              <a:t>✔  Mongoose ORM Schema</a:t>
-            </a:r>
-          </a:p>
-          <a:p>
-            <a:pPr>
-              <a:spcBef>
-                <a:spcPts val="800"/>
-              </a:spcBef>
-              <a:defRPr sz="1500">
-                <a:solidFill>
-                  <a:srgbClr val="1E293B"/>
-                </a:solidFill>
-                <a:latin typeface="Arial"/>
-              </a:defRPr>
-            </a:pPr>
-            <a:r>
-              <a:t>✔  JWT (Auth Tokens)</a:t>
-            </a:r>
-          </a:p>
-          <a:p>
-            <a:pPr>
-              <a:spcBef>
-                <a:spcPts val="800"/>
-              </a:spcBef>
-              <a:defRPr sz="1500">
-                <a:solidFill>
-                  <a:srgbClr val="1E293B"/>
-                </a:solidFill>
-                <a:latin typeface="Arial"/>
-              </a:defRPr>
-            </a:pPr>
-            <a:r>
-              <a:t>✔  Nodemailer (OTP Delivery)</a:t>
+              <a:rPr sz="1400" b="1">
+                <a:solidFill>
+                  <a:srgbClr val="333333"/>
+                </a:solidFill>
+                <a:latin typeface="Segoe UI"/>
+              </a:rPr>
+              <a:t>Backend ⚙️
+</a:t>
+            </a:r>
+          </a:p>
+          <a:p>
+            <a:pPr/>
+            <a:r>
+              <a:rPr sz="1150" b="0">
+                <a:solidFill>
+                  <a:srgbClr val="333333"/>
+                </a:solidFill>
+                <a:latin typeface="Segoe UI"/>
+              </a:rPr>
+              <a:t>✔ Node.js &amp; Express</a:t>
+            </a:r>
+          </a:p>
+          <a:p>
+            <a:pPr/>
+            <a:r>
+              <a:rPr sz="1150" b="0">
+                <a:solidFill>
+                  <a:srgbClr val="333333"/>
+                </a:solidFill>
+                <a:latin typeface="Segoe UI"/>
+              </a:rPr>
+              <a:t>✔ MongoDB &amp; Mongoose ORM</a:t>
+            </a:r>
+          </a:p>
+          <a:p>
+            <a:pPr/>
+            <a:r>
+              <a:rPr sz="1150" b="0">
+                <a:solidFill>
+                  <a:srgbClr val="333333"/>
+                </a:solidFill>
+                <a:latin typeface="Segoe UI"/>
+              </a:rPr>
+              <a:t>✔ JWT for secure logins</a:t>
+            </a:r>
+          </a:p>
+          <a:p>
+            <a:pPr/>
+            <a:r>
+              <a:rPr sz="1150" b="0">
+                <a:solidFill>
+                  <a:srgbClr val="333333"/>
+                </a:solidFill>
+                <a:latin typeface="Segoe UI"/>
+              </a:rPr>
+              <a:t>✔ Nodemailer for email OTPs</a:t>
             </a:r>
           </a:p>
         </p:txBody>
@@ -4803,87 +4786,62 @@
               </a:defRPr>
             </a:pPr>
             <a:r>
-              <a:t>DevOps &amp; CI/CD 🚀</a:t>
-            </a:r>
-          </a:p>
-          <a:p>
-            <a:pPr>
-              <a:spcBef>
-                <a:spcPts val="800"/>
-              </a:spcBef>
-              <a:defRPr sz="1500">
-                <a:solidFill>
-                  <a:srgbClr val="1E293B"/>
-                </a:solidFill>
-                <a:latin typeface="Arial"/>
-              </a:defRPr>
-            </a:pPr>
-            <a:r>
-              <a:t>✔  GitHub Actions Workflow</a:t>
-            </a:r>
-          </a:p>
-          <a:p>
-            <a:pPr>
-              <a:spcBef>
-                <a:spcPts val="800"/>
-              </a:spcBef>
-              <a:defRPr sz="1500">
-                <a:solidFill>
-                  <a:srgbClr val="1E293B"/>
-                </a:solidFill>
-                <a:latin typeface="Arial"/>
-              </a:defRPr>
-            </a:pPr>
-            <a:r>
-              <a:t>✔  In-Memory Test Runners</a:t>
-            </a:r>
-          </a:p>
-          <a:p>
-            <a:pPr>
-              <a:spcBef>
-                <a:spcPts val="800"/>
-              </a:spcBef>
-              <a:defRPr sz="1500">
-                <a:solidFill>
-                  <a:srgbClr val="1E293B"/>
-                </a:solidFill>
-                <a:latin typeface="Arial"/>
-              </a:defRPr>
-            </a:pPr>
-            <a:r>
-              <a:t>✔  Docker Containerization</a:t>
-            </a:r>
-          </a:p>
-          <a:p>
-            <a:pPr>
-              <a:spcBef>
-                <a:spcPts val="800"/>
-              </a:spcBef>
-              <a:defRPr sz="1500">
-                <a:solidFill>
-                  <a:srgbClr val="1E293B"/>
-                </a:solidFill>
-                <a:latin typeface="Arial"/>
-              </a:defRPr>
-            </a:pPr>
-            <a:r>
-              <a:t>✔  Docker Compose Orchestration</a:t>
-            </a:r>
-          </a:p>
-          <a:p>
-            <a:pPr>
-              <a:spcBef>
-                <a:spcPts val="800"/>
-              </a:spcBef>
-              <a:defRPr sz="1500">
-                <a:solidFill>
-                  <a:srgbClr val="1E293B"/>
-                </a:solidFill>
-                <a:latin typeface="Arial"/>
-              </a:defRPr>
-            </a:pPr>
-            <a:r>
-              <a:t>✔  Local Bridge Networks</a:t>
+              <a:rPr sz="1400" b="1">
+                <a:solidFill>
+                  <a:srgbClr val="333333"/>
+                </a:solidFill>
+                <a:latin typeface="Segoe UI"/>
+              </a:rPr>
+              <a:t>DevOps &amp; CI/CD 🚀
+</a:t>
+            </a:r>
+          </a:p>
+          <a:p>
+            <a:pPr/>
+            <a:r>
+              <a:rPr sz="1150" b="0">
+                <a:solidFill>
+                  <a:srgbClr val="333333"/>
+                </a:solidFill>
+                <a:latin typeface="Segoe UI"/>
+              </a:rPr>
+              <a:t>✔ GitHub Actions (Cloud CI)</a:t>
+            </a:r>
+          </a:p>
+          <a:p>
+            <a:pPr/>
+            <a:r>
+              <a:rPr sz="1150" b="0">
+                <a:solidFill>
+                  <a:srgbClr val="333333"/>
+                </a:solidFill>
+                <a:latin typeface="Segoe UI"/>
+              </a:rPr>
+              <a:t>✔ Jenkins (Local CI/CD)</a:t>
+            </a:r>
+          </a:p>
+          <a:p>
+            <a:pPr/>
+            <a:r>
+              <a:rPr sz="1150" b="0">
+                <a:solidFill>
+                  <a:srgbClr val="333333"/>
+                </a:solidFill>
+                <a:latin typeface="Segoe UI"/>
+              </a:rPr>
+              <a:t>✔ Docker Containerization</a:t>
+            </a:r>
+          </a:p>
+          <a:p>
+            <a:pPr/>
+            <a:r>
+              <a:rPr sz="1150" b="0">
+                <a:solidFill>
+                  <a:srgbClr val="333333"/>
+                </a:solidFill>
+                <a:latin typeface="Segoe UI"/>
+              </a:rPr>
+              <a:t>✔ Docker Compose Orchestration</a:t>
             </a:r>
           </a:p>
         </p:txBody>
@@ -5119,71 +5077,62 @@
               </a:defRPr>
             </a:pPr>
             <a:r>
-              <a:t>How ProManage Components Interact</a:t>
-            </a:r>
-          </a:p>
-          <a:p>
-            <a:pPr>
-              <a:spcAft>
-                <a:spcPts val="1500"/>
-              </a:spcAft>
-              <a:defRPr sz="1500">
-                <a:solidFill>
-                  <a:srgbClr val="1E293B"/>
-                </a:solidFill>
-                <a:latin typeface="Arial"/>
-              </a:defRPr>
-            </a:pPr>
-            <a:r>
-              <a:t>✔  Client-Server Communication: React frontend serves the UI client-side, forwarding `/api` operations to the Express backend server dynamically configured through a proxy layer.</a:t>
-            </a:r>
-          </a:p>
-          <a:p>
-            <a:pPr>
-              <a:spcAft>
-                <a:spcPts val="1500"/>
-              </a:spcAft>
-              <a:defRPr sz="1500">
-                <a:solidFill>
-                  <a:srgbClr val="1E293B"/>
-                </a:solidFill>
-                <a:latin typeface="Arial"/>
-              </a:defRPr>
-            </a:pPr>
-            <a:r>
-              <a:t>✔  Role-Based API Guarding: The server processes requests through authentication and authorization middlewares to restrict admin endpoints, project analytics, and task updates.</a:t>
-            </a:r>
-          </a:p>
-          <a:p>
-            <a:pPr>
-              <a:spcAft>
-                <a:spcPts val="1500"/>
-              </a:spcAft>
-              <a:defRPr sz="1500">
-                <a:solidFill>
-                  <a:srgbClr val="1E293B"/>
-                </a:solidFill>
-                <a:latin typeface="Arial"/>
-              </a:defRPr>
-            </a:pPr>
-            <a:r>
-              <a:t>✔  Database Architecture: Core entities (Users, Projects, Tasks, Activities) are connected via standard MongoDB ObjectId relations. In-memory databases are utilized during automated testing pipelines.</a:t>
-            </a:r>
-          </a:p>
-          <a:p>
-            <a:pPr>
-              <a:spcAft>
-                <a:spcPts val="1500"/>
-              </a:spcAft>
-              <a:defRPr sz="1500">
-                <a:solidFill>
-                  <a:srgbClr val="1E293B"/>
-                </a:solidFill>
-                <a:latin typeface="Arial"/>
-              </a:defRPr>
-            </a:pPr>
-            <a:r>
-              <a:t>✔  Container Isolation: Separate Docker containers isolate services within a custom bridge network, allowing backend endpoints to target 'mongodb:27017' internally while mapped safely on the host machine.</a:t>
+              <a:rPr sz="1600" b="1">
+                <a:solidFill>
+                  <a:srgbClr val="333333"/>
+                </a:solidFill>
+                <a:latin typeface="Segoe UI"/>
+              </a:rPr>
+              <a:t>How ProManage Works (Simple Architecture)
+</a:t>
+            </a:r>
+          </a:p>
+          <a:p>
+            <a:pPr/>
+            <a:r>
+              <a:rPr sz="1300" b="0">
+                <a:solidFill>
+                  <a:srgbClr val="333333"/>
+                </a:solidFill>
+                <a:latin typeface="Segoe UI"/>
+              </a:rPr>
+              <a:t>✔ Client-Server Flow: The React frontend displays the UI and makes API calls to the Express backend.</a:t>
+            </a:r>
+          </a:p>
+          <a:p>
+            <a:pPr/>
+            <a:r>
+              <a:rPr sz="1300" b="0">
+                <a:solidFill>
+                  <a:srgbClr val="333333"/>
+                </a:solidFill>
+                <a:latin typeface="Segoe UI"/>
+              </a:rPr>
+              <a:t>✔ Security Check: Backend middleware checks the JWT token and user role before allowing access to settings.</a:t>
+            </a:r>
+          </a:p>
+          <a:p>
+            <a:pPr/>
+            <a:r>
+              <a:rPr sz="1300" b="0">
+                <a:solidFill>
+                  <a:srgbClr val="333333"/>
+                </a:solidFill>
+                <a:latin typeface="Segoe UI"/>
+              </a:rPr>
+              <a:t>✔ Database: MongoDB stores all users, projects, tasks, and audit logs with clean relations.</a:t>
+            </a:r>
+          </a:p>
+          <a:p>
+            <a:pPr/>
+            <a:r>
+              <a:rPr sz="1300" b="0">
+                <a:solidFill>
+                  <a:srgbClr val="333333"/>
+                </a:solidFill>
+                <a:latin typeface="Segoe UI"/>
+              </a:rPr>
+              <a:t>✔ Containers: Docker separates frontend, backend, and database so they run isolated from host conflicts.</a:t>
             </a:r>
           </a:p>
         </p:txBody>
@@ -5419,55 +5368,50 @@
               </a:defRPr>
             </a:pPr>
             <a:r>
-              <a:t>GitHub Actions CI Pipeline</a:t>
-            </a:r>
-          </a:p>
-          <a:p>
-            <a:pPr>
-              <a:spcAft>
-                <a:spcPts val="1200"/>
-              </a:spcAft>
-              <a:defRPr sz="1500">
-                <a:solidFill>
-                  <a:srgbClr val="1E293B"/>
-                </a:solidFill>
-                <a:latin typeface="Arial"/>
-              </a:defRPr>
-            </a:pPr>
-            <a:r>
-              <a:t>• Triggered on push/PR: Automates quality gates whenever code changes are sent to 'main'.</a:t>
-            </a:r>
-          </a:p>
-          <a:p>
-            <a:pPr>
-              <a:spcAft>
-                <a:spcPts val="1200"/>
-              </a:spcAft>
-              <a:defRPr sz="1500">
-                <a:solidFill>
-                  <a:srgbClr val="1E293B"/>
-                </a:solidFill>
-                <a:latin typeface="Arial"/>
-              </a:defRPr>
-            </a:pPr>
-            <a:r>
-              <a:t>• Backend CI Job: Standardizes testing on ubuntu-22.04, spins up in-memory MongoDB, injects JWT secrets dynamically, and runs 61 core API tests.</a:t>
-            </a:r>
-          </a:p>
-          <a:p>
-            <a:pPr>
-              <a:spcAft>
-                <a:spcPts val="1200"/>
-              </a:spcAft>
-              <a:defRPr sz="1500">
-                <a:solidFill>
-                  <a:srgbClr val="1E293B"/>
-                </a:solidFill>
-                <a:latin typeface="Arial"/>
-              </a:defRPr>
-            </a:pPr>
-            <a:r>
-              <a:t>• Frontend CI Job: Installs client packages, validates TypeScript typechecking, and compiles Vite assets successfully.</a:t>
+              <a:rPr sz="1600" b="1">
+                <a:solidFill>
+                  <a:srgbClr val="333333"/>
+                </a:solidFill>
+                <a:latin typeface="Segoe UI"/>
+              </a:rPr>
+              <a:t>GitHub Actions (Cloud Verification)
+</a:t>
+            </a:r>
+          </a:p>
+          <a:p>
+            <a:pPr/>
+            <a:r>
+              <a:rPr sz="1300" b="0">
+                <a:solidFill>
+                  <a:srgbClr val="333333"/>
+                </a:solidFill>
+                <a:latin typeface="Segoe UI"/>
+              </a:rPr>
+              <a:t>• Auto Run: Triggers automatically on every code push to GitHub.</a:t>
+            </a:r>
+          </a:p>
+          <a:p>
+            <a:pPr/>
+            <a:r>
+              <a:rPr sz="1300" b="0">
+                <a:solidFill>
+                  <a:srgbClr val="333333"/>
+                </a:solidFill>
+                <a:latin typeface="Segoe UI"/>
+              </a:rPr>
+              <a:t>• Backend CI: Runs 61 API tests using an in-memory database to verify API safety.</a:t>
+            </a:r>
+          </a:p>
+          <a:p>
+            <a:pPr/>
+            <a:r>
+              <a:rPr sz="1300" b="0">
+                <a:solidFill>
+                  <a:srgbClr val="333333"/>
+                </a:solidFill>
+                <a:latin typeface="Segoe UI"/>
+              </a:rPr>
+              <a:t>• Frontend CI: Checks TypeScript types and builds Vite static assets.</a:t>
             </a:r>
           </a:p>
         </p:txBody>
@@ -5506,55 +5450,50 @@
               </a:defRPr>
             </a:pPr>
             <a:r>
-              <a:t>Docker Compose Orchestration</a:t>
-            </a:r>
-          </a:p>
-          <a:p>
-            <a:pPr>
-              <a:spcAft>
-                <a:spcPts val="1200"/>
-              </a:spcAft>
-              <a:defRPr sz="1500">
-                <a:solidFill>
-                  <a:srgbClr val="1E293B"/>
-                </a:solidFill>
-                <a:latin typeface="Arial"/>
-              </a:defRPr>
-            </a:pPr>
-            <a:r>
-              <a:t>• Multi-Container Setup: Orchestrates frontend, backend, and mongodb services dynamically.</a:t>
-            </a:r>
-          </a:p>
-          <a:p>
-            <a:pPr>
-              <a:spcAft>
-                <a:spcPts val="1200"/>
-              </a:spcAft>
-              <a:defRPr sz="1500">
-                <a:solidFill>
-                  <a:srgbClr val="1E293B"/>
-                </a:solidFill>
-                <a:latin typeface="Arial"/>
-              </a:defRPr>
-            </a:pPr>
-            <a:r>
-              <a:t>• Conflict Free Ports: Maps database container port internally while publishing safely to host on port 27018 to avoid host conflicts.</a:t>
-            </a:r>
-          </a:p>
-          <a:p>
-            <a:pPr>
-              <a:spcAft>
-                <a:spcPts val="1200"/>
-              </a:spcAft>
-              <a:defRPr sz="1500">
-                <a:solidFill>
-                  <a:srgbClr val="1E293B"/>
-                </a:solidFill>
-                <a:latin typeface="Arial"/>
-              </a:defRPr>
-            </a:pPr>
-            <a:r>
-              <a:t>• Developer Live Reload: Integrates directory volume bindings (excluding node_modules) allowing developers to see updates live inside containerized instances.</a:t>
+              <a:rPr sz="1600" b="1">
+                <a:solidFill>
+                  <a:srgbClr val="333333"/>
+                </a:solidFill>
+                <a:latin typeface="Segoe UI"/>
+              </a:rPr>
+              <a:t>Jenkins (Local Pipeline &amp; Deploy)
+</a:t>
+            </a:r>
+          </a:p>
+          <a:p>
+            <a:pPr/>
+            <a:r>
+              <a:rPr sz="1300" b="0">
+                <a:solidFill>
+                  <a:srgbClr val="333333"/>
+                </a:solidFill>
+                <a:latin typeface="Segoe UI"/>
+              </a:rPr>
+              <a:t>• Declarative Pipeline: Uses a custom Jenkinsfile designed to run cross-platform (Windows/Linux).</a:t>
+            </a:r>
+          </a:p>
+          <a:p>
+            <a:pPr/>
+            <a:r>
+              <a:rPr sz="1300" b="0">
+                <a:solidFill>
+                  <a:srgbClr val="333333"/>
+                </a:solidFill>
+                <a:latin typeface="Segoe UI"/>
+              </a:rPr>
+              <a:t>• Auto Build &amp; Test: Pulls repo, runs 61 backend integration tests, and builds Docker images.</a:t>
+            </a:r>
+          </a:p>
+          <a:p>
+            <a:pPr/>
+            <a:r>
+              <a:rPr sz="1300" b="0">
+                <a:solidFill>
+                  <a:srgbClr val="333333"/>
+                </a:solidFill>
+                <a:latin typeface="Segoe UI"/>
+              </a:rPr>
+              <a:t>• Local Deployment: Automatically deploys and updates the app containers on local Docker.</a:t>
             </a:r>
           </a:p>
         </p:txBody>
@@ -5662,71 +5601,62 @@
               </a:defRPr>
             </a:pPr>
             <a:r>
-              <a:t>Conclusion &amp; Future Roadmap</a:t>
-            </a:r>
-          </a:p>
-          <a:p>
-            <a:pPr algn="ctr">
-              <a:spcAft>
-                <a:spcPts val="1200"/>
-              </a:spcAft>
-              <a:defRPr sz="1800">
-                <a:solidFill>
-                  <a:srgbClr val="FFFFFF"/>
-                </a:solidFill>
-                <a:latin typeface="Arial"/>
-              </a:defRPr>
-            </a:pPr>
-            <a:r>
-              <a:t>✔  ProManage delivers a complete, secure, and production-ready SaaS model for modern teams.</a:t>
-            </a:r>
-          </a:p>
-          <a:p>
-            <a:pPr algn="ctr">
-              <a:spcAft>
-                <a:spcPts val="1200"/>
-              </a:spcAft>
-              <a:defRPr sz="1800">
-                <a:solidFill>
-                  <a:srgbClr val="FFFFFF"/>
-                </a:solidFill>
-                <a:latin typeface="Arial"/>
-              </a:defRPr>
-            </a:pPr>
-            <a:r>
-              <a:t>✔  Provides unique value by unifying traditional task tracking with DevOps resource metrics.</a:t>
-            </a:r>
-          </a:p>
-          <a:p>
-            <a:pPr algn="ctr">
-              <a:spcAft>
-                <a:spcPts val="1200"/>
-              </a:spcAft>
-              <a:defRPr sz="1800">
-                <a:solidFill>
-                  <a:srgbClr val="FFFFFF"/>
-                </a:solidFill>
-                <a:latin typeface="Arial"/>
-              </a:defRPr>
-            </a:pPr>
-            <a:r>
-              <a:t>✔  Roadmap: Integration with real Kubernetes clusters and cloud providers (AWS, GCP).</a:t>
-            </a:r>
-          </a:p>
-          <a:p>
-            <a:pPr algn="ctr">
-              <a:spcAft>
-                <a:spcPts val="1200"/>
-              </a:spcAft>
-              <a:defRPr sz="1800">
-                <a:solidFill>
-                  <a:srgbClr val="FFFFFF"/>
-                </a:solidFill>
-                <a:latin typeface="Arial"/>
-              </a:defRPr>
-            </a:pPr>
-            <a:r>
-              <a:t>✔  Roadmap: Machine learning models for task completion estimation and sprint velocity prediction.</a:t>
+              <a:rPr sz="1800" b="1">
+                <a:solidFill>
+                  <a:srgbClr val="333333"/>
+                </a:solidFill>
+                <a:latin typeface="Segoe UI"/>
+              </a:rPr>
+              <a:t>Conclusion &amp; Future Roadmap
+</a:t>
+            </a:r>
+          </a:p>
+          <a:p>
+            <a:pPr/>
+            <a:r>
+              <a:rPr sz="1300" b="0">
+                <a:solidFill>
+                  <a:srgbClr val="333333"/>
+                </a:solidFill>
+                <a:latin typeface="Segoe UI"/>
+              </a:rPr>
+              <a:t>✔ Summary: ProManage makes project management and DevOps easy by putting them on a single screen.</a:t>
+            </a:r>
+          </a:p>
+          <a:p>
+            <a:pPr/>
+            <a:r>
+              <a:rPr sz="1300" b="0">
+                <a:solidFill>
+                  <a:srgbClr val="333333"/>
+                </a:solidFill>
+                <a:latin typeface="Segoe UI"/>
+              </a:rPr>
+              <a:t>✔ Future - Cloud Deployment: Auto-deploy to cloud hosts like AWS EC2 using CI/CD pipelines.</a:t>
+            </a:r>
+          </a:p>
+          <a:p>
+            <a:pPr/>
+            <a:r>
+              <a:rPr sz="1300" b="0">
+                <a:solidFill>
+                  <a:srgbClr val="333333"/>
+                </a:solidFill>
+                <a:latin typeface="Segoe UI"/>
+              </a:rPr>
+              <a:t>✔ Future - Kubernetes: Connect with Kubernetes clusters for enterprise scaling.</a:t>
+            </a:r>
+          </a:p>
+          <a:p>
+            <a:pPr/>
+            <a:r>
+              <a:rPr sz="1300" b="0">
+                <a:solidFill>
+                  <a:srgbClr val="333333"/>
+                </a:solidFill>
+                <a:latin typeface="Segoe UI"/>
+              </a:rPr>
+              <a:t>✔ Future - AI Estimator: Use machine learning models to predict task completion times.</a:t>
             </a:r>
           </a:p>
         </p:txBody>

</xml_diff>